<commit_message>
Finished reworking alpha diversity script
</commit_message>
<xml_diff>
--- a/Projects/Chapter1/community-assembly-edit.pptx
+++ b/Projects/Chapter1/community-assembly-edit.pptx
@@ -5,7 +5,7 @@
     <p:sldMasterId id="2147483648" r:id="rId1"/>
   </p:sldMasterIdLst>
   <p:notesMasterIdLst>
-    <p:notesMasterId r:id="rId31"/>
+    <p:notesMasterId r:id="rId34"/>
   </p:notesMasterIdLst>
   <p:sldIdLst>
     <p:sldId id="256" r:id="rId2"/>
@@ -15,28 +15,31 @@
     <p:sldId id="281" r:id="rId6"/>
     <p:sldId id="283" r:id="rId7"/>
     <p:sldId id="282" r:id="rId8"/>
-    <p:sldId id="287" r:id="rId9"/>
-    <p:sldId id="299" r:id="rId10"/>
-    <p:sldId id="300" r:id="rId11"/>
-    <p:sldId id="301" r:id="rId12"/>
-    <p:sldId id="302" r:id="rId13"/>
-    <p:sldId id="309" r:id="rId14"/>
-    <p:sldId id="310" r:id="rId15"/>
-    <p:sldId id="258" r:id="rId16"/>
-    <p:sldId id="259" r:id="rId17"/>
-    <p:sldId id="261" r:id="rId18"/>
-    <p:sldId id="277" r:id="rId19"/>
-    <p:sldId id="278" r:id="rId20"/>
-    <p:sldId id="265" r:id="rId21"/>
-    <p:sldId id="293" r:id="rId22"/>
-    <p:sldId id="271" r:id="rId23"/>
-    <p:sldId id="260" r:id="rId24"/>
-    <p:sldId id="295" r:id="rId25"/>
-    <p:sldId id="262" r:id="rId26"/>
-    <p:sldId id="294" r:id="rId27"/>
-    <p:sldId id="298" r:id="rId28"/>
-    <p:sldId id="296" r:id="rId29"/>
-    <p:sldId id="297" r:id="rId30"/>
+    <p:sldId id="312" r:id="rId9"/>
+    <p:sldId id="313" r:id="rId10"/>
+    <p:sldId id="314" r:id="rId11"/>
+    <p:sldId id="287" r:id="rId12"/>
+    <p:sldId id="299" r:id="rId13"/>
+    <p:sldId id="300" r:id="rId14"/>
+    <p:sldId id="301" r:id="rId15"/>
+    <p:sldId id="302" r:id="rId16"/>
+    <p:sldId id="309" r:id="rId17"/>
+    <p:sldId id="310" r:id="rId18"/>
+    <p:sldId id="258" r:id="rId19"/>
+    <p:sldId id="259" r:id="rId20"/>
+    <p:sldId id="261" r:id="rId21"/>
+    <p:sldId id="277" r:id="rId22"/>
+    <p:sldId id="278" r:id="rId23"/>
+    <p:sldId id="265" r:id="rId24"/>
+    <p:sldId id="293" r:id="rId25"/>
+    <p:sldId id="271" r:id="rId26"/>
+    <p:sldId id="260" r:id="rId27"/>
+    <p:sldId id="295" r:id="rId28"/>
+    <p:sldId id="262" r:id="rId29"/>
+    <p:sldId id="294" r:id="rId30"/>
+    <p:sldId id="298" r:id="rId31"/>
+    <p:sldId id="296" r:id="rId32"/>
+    <p:sldId id="297" r:id="rId33"/>
   </p:sldIdLst>
   <p:sldSz cx="12192000" cy="6858000"/>
   <p:notesSz cx="6858000" cy="9144000"/>
@@ -6228,7 +6231,7 @@
         <a:lstStyle/>
         <a:p>
           <a:r>
-            <a:rPr lang="en-US" dirty="0"/>
+            <a:rPr lang="en-US" strike="sngStrike" dirty="0"/>
             <a:t>Remove singletons</a:t>
           </a:r>
         </a:p>
@@ -6301,7 +6304,11 @@
         <a:p>
           <a:r>
             <a:rPr lang="en-US" dirty="0"/>
-            <a:t>Remove ambiguous annotations and low abundance phyla</a:t>
+            <a:t>Remove ambiguous annotations </a:t>
+          </a:r>
+          <a:r>
+            <a:rPr lang="en-US" strike="sngStrike" dirty="0"/>
+            <a:t>and low abundance phyla</a:t>
           </a:r>
         </a:p>
       </dgm:t>
@@ -10479,7 +10486,7 @@
             <a:buNone/>
           </a:pPr>
           <a:r>
-            <a:rPr lang="en-US" sz="1700" kern="1200" dirty="0"/>
+            <a:rPr lang="en-US" sz="1700" strike="sngStrike" kern="1200" dirty="0"/>
             <a:t>Remove singletons</a:t>
           </a:r>
         </a:p>
@@ -10629,7 +10636,11 @@
           </a:pPr>
           <a:r>
             <a:rPr lang="en-US" sz="1700" kern="1200" dirty="0"/>
-            <a:t>Remove ambiguous annotations and low abundance phyla</a:t>
+            <a:t>Remove ambiguous annotations </a:t>
+          </a:r>
+          <a:r>
+            <a:rPr lang="en-US" sz="1700" strike="sngStrike" kern="1200" dirty="0"/>
+            <a:t>and low abundance phyla</a:t>
           </a:r>
         </a:p>
       </dsp:txBody>
@@ -22323,7 +22334,7 @@
           <a:p>
             <a:fld id="{50055017-D10A-7E41-A628-FFBA6D86E32F}" type="datetimeFigureOut">
               <a:rPr lang="en-US" smtClean="0"/>
-              <a:t>4/22/21</a:t>
+              <a:t>4/28/21</a:t>
             </a:fld>
             <a:endParaRPr lang="en-US"/>
           </a:p>
@@ -22889,7 +22900,7 @@
           <a:p>
             <a:fld id="{91AE2140-D502-214A-B76B-E0784B2C949B}" type="slidenum">
               <a:rPr lang="en-US" smtClean="0"/>
-              <a:t>15</a:t>
+              <a:t>18</a:t>
             </a:fld>
             <a:endParaRPr lang="en-US"/>
           </a:p>
@@ -23030,7 +23041,7 @@
           <a:p>
             <a:fld id="{91AE2140-D502-214A-B76B-E0784B2C949B}" type="slidenum">
               <a:rPr lang="en-US" smtClean="0"/>
-              <a:t>16</a:t>
+              <a:t>19</a:t>
             </a:fld>
             <a:endParaRPr lang="en-US"/>
           </a:p>
@@ -23343,7 +23354,7 @@
           <a:p>
             <a:fld id="{91AE2140-D502-214A-B76B-E0784B2C949B}" type="slidenum">
               <a:rPr lang="en-US" smtClean="0"/>
-              <a:t>17</a:t>
+              <a:t>20</a:t>
             </a:fld>
             <a:endParaRPr lang="en-US"/>
           </a:p>
@@ -23530,7 +23541,7 @@
           <a:p>
             <a:fld id="{91AE2140-D502-214A-B76B-E0784B2C949B}" type="slidenum">
               <a:rPr lang="en-US" smtClean="0"/>
-              <a:t>18</a:t>
+              <a:t>21</a:t>
             </a:fld>
             <a:endParaRPr lang="en-US"/>
           </a:p>
@@ -23866,7 +23877,7 @@
           <a:p>
             <a:fld id="{91AE2140-D502-214A-B76B-E0784B2C949B}" type="slidenum">
               <a:rPr lang="en-US" smtClean="0"/>
-              <a:t>19</a:t>
+              <a:t>22</a:t>
             </a:fld>
             <a:endParaRPr lang="en-US"/>
           </a:p>
@@ -24323,7 +24334,7 @@
           <a:p>
             <a:fld id="{91AE2140-D502-214A-B76B-E0784B2C949B}" type="slidenum">
               <a:rPr lang="en-US" smtClean="0"/>
-              <a:t>20</a:t>
+              <a:t>23</a:t>
             </a:fld>
             <a:endParaRPr lang="en-US"/>
           </a:p>
@@ -24444,7 +24455,7 @@
           <a:p>
             <a:fld id="{91AE2140-D502-214A-B76B-E0784B2C949B}" type="slidenum">
               <a:rPr lang="en-US" smtClean="0"/>
-              <a:t>22</a:t>
+              <a:t>25</a:t>
             </a:fld>
             <a:endParaRPr lang="en-US"/>
           </a:p>
@@ -24643,7 +24654,7 @@
           <a:p>
             <a:fld id="{91AE2140-D502-214A-B76B-E0784B2C949B}" type="slidenum">
               <a:rPr lang="en-US" smtClean="0"/>
-              <a:t>23</a:t>
+              <a:t>26</a:t>
             </a:fld>
             <a:endParaRPr lang="en-US"/>
           </a:p>
@@ -24745,7 +24756,7 @@
           <a:p>
             <a:fld id="{91AE2140-D502-214A-B76B-E0784B2C949B}" type="slidenum">
               <a:rPr lang="en-US" smtClean="0"/>
-              <a:t>24</a:t>
+              <a:t>27</a:t>
             </a:fld>
             <a:endParaRPr lang="en-US"/>
           </a:p>
@@ -24876,7 +24887,7 @@
           <a:p>
             <a:fld id="{91AE2140-D502-214A-B76B-E0784B2C949B}" type="slidenum">
               <a:rPr lang="en-US" smtClean="0"/>
-              <a:t>25</a:t>
+              <a:t>28</a:t>
             </a:fld>
             <a:endParaRPr lang="en-US"/>
           </a:p>
@@ -25166,7 +25177,7 @@
           <a:p>
             <a:fld id="{91AE2140-D502-214A-B76B-E0784B2C949B}" type="slidenum">
               <a:rPr lang="en-US" smtClean="0"/>
-              <a:t>26</a:t>
+              <a:t>29</a:t>
             </a:fld>
             <a:endParaRPr lang="en-US"/>
           </a:p>
@@ -25320,7 +25331,7 @@
           <a:p>
             <a:fld id="{91AE2140-D502-214A-B76B-E0784B2C949B}" type="slidenum">
               <a:rPr lang="en-US" smtClean="0"/>
-              <a:t>27</a:t>
+              <a:t>30</a:t>
             </a:fld>
             <a:endParaRPr lang="en-US"/>
           </a:p>
@@ -25454,7 +25465,7 @@
           <a:p>
             <a:fld id="{91AE2140-D502-214A-B76B-E0784B2C949B}" type="slidenum">
               <a:rPr lang="en-US" smtClean="0"/>
-              <a:t>28</a:t>
+              <a:t>31</a:t>
             </a:fld>
             <a:endParaRPr lang="en-US"/>
           </a:p>
@@ -26615,7 +26626,7 @@
           <a:p>
             <a:fld id="{91AE2140-D502-214A-B76B-E0784B2C949B}" type="slidenum">
               <a:rPr lang="en-US" smtClean="0"/>
-              <a:t>9</a:t>
+              <a:t>12</a:t>
             </a:fld>
             <a:endParaRPr lang="en-US"/>
           </a:p>
@@ -26733,7 +26744,7 @@
           <a:p>
             <a:fld id="{91AE2140-D502-214A-B76B-E0784B2C949B}" type="slidenum">
               <a:rPr lang="en-US" smtClean="0"/>
-              <a:t>10</a:t>
+              <a:t>13</a:t>
             </a:fld>
             <a:endParaRPr lang="en-US"/>
           </a:p>
@@ -26912,7 +26923,7 @@
           <a:p>
             <a:fld id="{91AE2140-D502-214A-B76B-E0784B2C949B}" type="slidenum">
               <a:rPr lang="en-US" smtClean="0"/>
-              <a:t>13</a:t>
+              <a:t>16</a:t>
             </a:fld>
             <a:endParaRPr lang="en-US"/>
           </a:p>
@@ -26999,7 +27010,7 @@
           <a:p>
             <a:fld id="{91AE2140-D502-214A-B76B-E0784B2C949B}" type="slidenum">
               <a:rPr lang="en-US" smtClean="0"/>
-              <a:t>14</a:t>
+              <a:t>17</a:t>
             </a:fld>
             <a:endParaRPr lang="en-US"/>
           </a:p>
@@ -27165,7 +27176,7 @@
           <a:p>
             <a:fld id="{630F8F96-A0AC-FA40-A1E6-5325FF9AFD7F}" type="datetimeFigureOut">
               <a:rPr lang="en-US" smtClean="0"/>
-              <a:t>4/22/21</a:t>
+              <a:t>4/28/21</a:t>
             </a:fld>
             <a:endParaRPr lang="en-US"/>
           </a:p>
@@ -27363,7 +27374,7 @@
           <a:p>
             <a:fld id="{630F8F96-A0AC-FA40-A1E6-5325FF9AFD7F}" type="datetimeFigureOut">
               <a:rPr lang="en-US" smtClean="0"/>
-              <a:t>4/22/21</a:t>
+              <a:t>4/28/21</a:t>
             </a:fld>
             <a:endParaRPr lang="en-US"/>
           </a:p>
@@ -27571,7 +27582,7 @@
           <a:p>
             <a:fld id="{630F8F96-A0AC-FA40-A1E6-5325FF9AFD7F}" type="datetimeFigureOut">
               <a:rPr lang="en-US" smtClean="0"/>
-              <a:t>4/22/21</a:t>
+              <a:t>4/28/21</a:t>
             </a:fld>
             <a:endParaRPr lang="en-US"/>
           </a:p>
@@ -27769,7 +27780,7 @@
           <a:p>
             <a:fld id="{630F8F96-A0AC-FA40-A1E6-5325FF9AFD7F}" type="datetimeFigureOut">
               <a:rPr lang="en-US" smtClean="0"/>
-              <a:t>4/22/21</a:t>
+              <a:t>4/28/21</a:t>
             </a:fld>
             <a:endParaRPr lang="en-US"/>
           </a:p>
@@ -28044,7 +28055,7 @@
           <a:p>
             <a:fld id="{630F8F96-A0AC-FA40-A1E6-5325FF9AFD7F}" type="datetimeFigureOut">
               <a:rPr lang="en-US" smtClean="0"/>
-              <a:t>4/22/21</a:t>
+              <a:t>4/28/21</a:t>
             </a:fld>
             <a:endParaRPr lang="en-US"/>
           </a:p>
@@ -28309,7 +28320,7 @@
           <a:p>
             <a:fld id="{630F8F96-A0AC-FA40-A1E6-5325FF9AFD7F}" type="datetimeFigureOut">
               <a:rPr lang="en-US" smtClean="0"/>
-              <a:t>4/22/21</a:t>
+              <a:t>4/28/21</a:t>
             </a:fld>
             <a:endParaRPr lang="en-US"/>
           </a:p>
@@ -28721,7 +28732,7 @@
           <a:p>
             <a:fld id="{630F8F96-A0AC-FA40-A1E6-5325FF9AFD7F}" type="datetimeFigureOut">
               <a:rPr lang="en-US" smtClean="0"/>
-              <a:t>4/22/21</a:t>
+              <a:t>4/28/21</a:t>
             </a:fld>
             <a:endParaRPr lang="en-US"/>
           </a:p>
@@ -28862,7 +28873,7 @@
           <a:p>
             <a:fld id="{630F8F96-A0AC-FA40-A1E6-5325FF9AFD7F}" type="datetimeFigureOut">
               <a:rPr lang="en-US" smtClean="0"/>
-              <a:t>4/22/21</a:t>
+              <a:t>4/28/21</a:t>
             </a:fld>
             <a:endParaRPr lang="en-US"/>
           </a:p>
@@ -28975,7 +28986,7 @@
           <a:p>
             <a:fld id="{630F8F96-A0AC-FA40-A1E6-5325FF9AFD7F}" type="datetimeFigureOut">
               <a:rPr lang="en-US" smtClean="0"/>
-              <a:t>4/22/21</a:t>
+              <a:t>4/28/21</a:t>
             </a:fld>
             <a:endParaRPr lang="en-US"/>
           </a:p>
@@ -29286,7 +29297,7 @@
           <a:p>
             <a:fld id="{630F8F96-A0AC-FA40-A1E6-5325FF9AFD7F}" type="datetimeFigureOut">
               <a:rPr lang="en-US" smtClean="0"/>
-              <a:t>4/22/21</a:t>
+              <a:t>4/28/21</a:t>
             </a:fld>
             <a:endParaRPr lang="en-US"/>
           </a:p>
@@ -29574,7 +29585,7 @@
           <a:p>
             <a:fld id="{630F8F96-A0AC-FA40-A1E6-5325FF9AFD7F}" type="datetimeFigureOut">
               <a:rPr lang="en-US" smtClean="0"/>
-              <a:t>4/22/21</a:t>
+              <a:t>4/28/21</a:t>
             </a:fld>
             <a:endParaRPr lang="en-US"/>
           </a:p>
@@ -29815,7 +29826,7 @@
           <a:p>
             <a:fld id="{630F8F96-A0AC-FA40-A1E6-5325FF9AFD7F}" type="datetimeFigureOut">
               <a:rPr lang="en-US" smtClean="0"/>
-              <a:t>4/22/21</a:t>
+              <a:t>4/28/21</a:t>
             </a:fld>
             <a:endParaRPr lang="en-US"/>
           </a:p>
@@ -30340,6 +30351,461 @@
           <p:cNvPr id="2" name="Title 1">
             <a:extLst>
               <a:ext uri="{FF2B5EF4-FFF2-40B4-BE49-F238E27FC236}">
+                <a16:creationId xmlns:a16="http://schemas.microsoft.com/office/drawing/2014/main" id="{7DF1C9DD-11DF-4E44-985B-21C037761EC9}"/>
+              </a:ext>
+            </a:extLst>
+          </p:cNvPr>
+          <p:cNvSpPr>
+            <a:spLocks noGrp="1"/>
+          </p:cNvSpPr>
+          <p:nvPr>
+            <p:ph type="title"/>
+          </p:nvPr>
+        </p:nvSpPr>
+        <p:spPr/>
+        <p:txBody>
+          <a:bodyPr/>
+          <a:lstStyle/>
+          <a:p>
+            <a:r>
+              <a:rPr lang="en-US" dirty="0"/>
+              <a:t>Shannon Diversity</a:t>
+            </a:r>
+          </a:p>
+        </p:txBody>
+      </p:sp>
+      <p:sp>
+        <p:nvSpPr>
+          <p:cNvPr id="4" name="TextBox 3">
+            <a:extLst>
+              <a:ext uri="{FF2B5EF4-FFF2-40B4-BE49-F238E27FC236}">
+                <a16:creationId xmlns:a16="http://schemas.microsoft.com/office/drawing/2014/main" id="{3965FD7F-B96E-6340-AFDE-61B01C5D8419}"/>
+              </a:ext>
+            </a:extLst>
+          </p:cNvPr>
+          <p:cNvSpPr txBox="1"/>
+          <p:nvPr/>
+        </p:nvSpPr>
+        <p:spPr>
+          <a:xfrm>
+            <a:off x="624468" y="1952793"/>
+            <a:ext cx="4958576" cy="3970318"/>
+          </a:xfrm>
+          <a:prstGeom prst="rect">
+            <a:avLst/>
+          </a:prstGeom>
+          <a:noFill/>
+        </p:spPr>
+        <p:txBody>
+          <a:bodyPr wrap="square" rtlCol="0">
+            <a:spAutoFit/>
+          </a:bodyPr>
+          <a:lstStyle/>
+          <a:p>
+            <a:r>
+              <a:rPr lang="en-US" dirty="0"/>
+              <a:t>Comparison of Shannon between Canada and Taylor glaciers</a:t>
+            </a:r>
+          </a:p>
+          <a:p>
+            <a:endParaRPr lang="en-US" dirty="0"/>
+          </a:p>
+          <a:p>
+            <a:r>
+              <a:rPr lang="en-US" dirty="0"/>
+              <a:t>Total community: Parametric assumptions not met. Unpaired two samples Wilcoxon test showed no significant difference (W=141, p= 0.61)</a:t>
+            </a:r>
+          </a:p>
+          <a:p>
+            <a:endParaRPr lang="en-US" dirty="0"/>
+          </a:p>
+          <a:p>
+            <a:r>
+              <a:rPr lang="en-US" dirty="0"/>
+              <a:t>Abundant community: Parametric assumptions not met. Unpaired two samples Wilcoxon test showed no significant difference (W=123, p= 0.91)</a:t>
+            </a:r>
+          </a:p>
+          <a:p>
+            <a:endParaRPr lang="en-US" dirty="0"/>
+          </a:p>
+          <a:p>
+            <a:r>
+              <a:rPr lang="en-US" dirty="0"/>
+              <a:t>Rare community: Parametric assumptions met. Unpaired two-sample t-test showed no significant difference (t=0.88, </a:t>
+            </a:r>
+            <a:r>
+              <a:rPr lang="en-US" dirty="0" err="1"/>
+              <a:t>df</a:t>
+            </a:r>
+            <a:r>
+              <a:rPr lang="en-US" dirty="0"/>
+              <a:t>=32, p=0.39)</a:t>
+            </a:r>
+          </a:p>
+        </p:txBody>
+      </p:sp>
+      <p:pic>
+        <p:nvPicPr>
+          <p:cNvPr id="7" name="Picture 6">
+            <a:extLst>
+              <a:ext uri="{FF2B5EF4-FFF2-40B4-BE49-F238E27FC236}">
+                <a16:creationId xmlns:a16="http://schemas.microsoft.com/office/drawing/2014/main" id="{F4D4DB36-92A8-DE48-92A8-AF3420263B6A}"/>
+              </a:ext>
+            </a:extLst>
+          </p:cNvPr>
+          <p:cNvPicPr>
+            <a:picLocks noChangeAspect="1"/>
+          </p:cNvPicPr>
+          <p:nvPr/>
+        </p:nvPicPr>
+        <p:blipFill>
+          <a:blip r:embed="rId2"/>
+          <a:stretch>
+            <a:fillRect/>
+          </a:stretch>
+        </p:blipFill>
+        <p:spPr>
+          <a:xfrm>
+            <a:off x="5874834" y="752707"/>
+            <a:ext cx="5486400" cy="5486400"/>
+          </a:xfrm>
+          <a:prstGeom prst="rect">
+            <a:avLst/>
+          </a:prstGeom>
+        </p:spPr>
+      </p:pic>
+      <p:pic>
+        <p:nvPicPr>
+          <p:cNvPr id="9" name="Picture 8">
+            <a:extLst>
+              <a:ext uri="{FF2B5EF4-FFF2-40B4-BE49-F238E27FC236}">
+                <a16:creationId xmlns:a16="http://schemas.microsoft.com/office/drawing/2014/main" id="{39BEE36E-189C-514C-8954-1457C1DB586C}"/>
+              </a:ext>
+            </a:extLst>
+          </p:cNvPr>
+          <p:cNvPicPr>
+            <a:picLocks noChangeAspect="1"/>
+          </p:cNvPicPr>
+          <p:nvPr/>
+        </p:nvPicPr>
+        <p:blipFill>
+          <a:blip r:embed="rId3"/>
+          <a:stretch>
+            <a:fillRect/>
+          </a:stretch>
+        </p:blipFill>
+        <p:spPr>
+          <a:xfrm>
+            <a:off x="8519531" y="4064127"/>
+            <a:ext cx="3464617" cy="1599809"/>
+          </a:xfrm>
+          <a:prstGeom prst="rect">
+            <a:avLst/>
+          </a:prstGeom>
+        </p:spPr>
+      </p:pic>
+    </p:spTree>
+    <p:extLst>
+      <p:ext uri="{BB962C8B-B14F-4D97-AF65-F5344CB8AC3E}">
+        <p14:creationId xmlns:p14="http://schemas.microsoft.com/office/powerpoint/2010/main" val="2000788017"/>
+      </p:ext>
+    </p:extLst>
+  </p:cSld>
+  <p:clrMapOvr>
+    <a:masterClrMapping/>
+  </p:clrMapOvr>
+</p:sld>
+</file>
+
+<file path=ppt/slides/slide11.xml><?xml version="1.0" encoding="utf-8"?>
+<p:sld xmlns:a="http://schemas.openxmlformats.org/drawingml/2006/main" xmlns:r="http://schemas.openxmlformats.org/officeDocument/2006/relationships" xmlns:p="http://schemas.openxmlformats.org/presentationml/2006/main">
+  <p:cSld>
+    <p:spTree>
+      <p:nvGrpSpPr>
+        <p:cNvPr id="1" name=""/>
+        <p:cNvGrpSpPr/>
+        <p:nvPr/>
+      </p:nvGrpSpPr>
+      <p:grpSpPr>
+        <a:xfrm>
+          <a:off x="0" y="0"/>
+          <a:ext cx="0" cy="0"/>
+          <a:chOff x="0" y="0"/>
+          <a:chExt cx="0" cy="0"/>
+        </a:xfrm>
+      </p:grpSpPr>
+      <p:sp>
+        <p:nvSpPr>
+          <p:cNvPr id="2" name="Title 1">
+            <a:extLst>
+              <a:ext uri="{FF2B5EF4-FFF2-40B4-BE49-F238E27FC236}">
+                <a16:creationId xmlns:a16="http://schemas.microsoft.com/office/drawing/2014/main" id="{F8883892-3D96-014B-BA22-D3A4750E524A}"/>
+              </a:ext>
+            </a:extLst>
+          </p:cNvPr>
+          <p:cNvSpPr>
+            <a:spLocks noGrp="1"/>
+          </p:cNvSpPr>
+          <p:nvPr>
+            <p:ph type="title"/>
+          </p:nvPr>
+        </p:nvSpPr>
+        <p:spPr>
+          <a:solidFill>
+            <a:srgbClr val="FFC003"/>
+          </a:solidFill>
+        </p:spPr>
+        <p:txBody>
+          <a:bodyPr/>
+          <a:lstStyle/>
+          <a:p>
+            <a:r>
+              <a:rPr lang="en-US" dirty="0">
+                <a:solidFill>
+                  <a:schemeClr val="bg1"/>
+                </a:solidFill>
+              </a:rPr>
+              <a:t>Multivariate Analysis</a:t>
+            </a:r>
+          </a:p>
+        </p:txBody>
+      </p:sp>
+      <p:sp>
+        <p:nvSpPr>
+          <p:cNvPr id="3" name="Content Placeholder 2">
+            <a:extLst>
+              <a:ext uri="{FF2B5EF4-FFF2-40B4-BE49-F238E27FC236}">
+                <a16:creationId xmlns:a16="http://schemas.microsoft.com/office/drawing/2014/main" id="{057D77B9-9D78-E74A-8AAE-82071815FD34}"/>
+              </a:ext>
+            </a:extLst>
+          </p:cNvPr>
+          <p:cNvSpPr>
+            <a:spLocks noGrp="1"/>
+          </p:cNvSpPr>
+          <p:nvPr>
+            <p:ph idx="1"/>
+          </p:nvPr>
+        </p:nvSpPr>
+        <p:spPr/>
+        <p:txBody>
+          <a:bodyPr>
+            <a:normAutofit/>
+          </a:bodyPr>
+          <a:lstStyle/>
+          <a:p>
+            <a:pPr marL="742950" indent="-742950">
+              <a:buFont typeface="+mj-lt"/>
+              <a:buAutoNum type="arabicPeriod"/>
+            </a:pPr>
+            <a:r>
+              <a:rPr lang="en-US" sz="4000" dirty="0"/>
+              <a:t>Alpha Diversity </a:t>
+            </a:r>
+          </a:p>
+          <a:p>
+            <a:pPr marL="742950" indent="-742950">
+              <a:buFont typeface="+mj-lt"/>
+              <a:buAutoNum type="arabicPeriod"/>
+            </a:pPr>
+            <a:r>
+              <a:rPr lang="en-US" sz="4000" dirty="0"/>
+              <a:t>Beta Diversity &amp; Ordination</a:t>
+            </a:r>
+          </a:p>
+          <a:p>
+            <a:pPr marL="742950" indent="-742950">
+              <a:buFont typeface="+mj-lt"/>
+              <a:buAutoNum type="arabicPeriod"/>
+            </a:pPr>
+            <a:r>
+              <a:rPr lang="en-US" sz="4000" dirty="0"/>
+              <a:t>ISAR and DDR</a:t>
+            </a:r>
+          </a:p>
+        </p:txBody>
+      </p:sp>
+    </p:spTree>
+    <p:extLst>
+      <p:ext uri="{BB962C8B-B14F-4D97-AF65-F5344CB8AC3E}">
+        <p14:creationId xmlns:p14="http://schemas.microsoft.com/office/powerpoint/2010/main" val="542213217"/>
+      </p:ext>
+    </p:extLst>
+  </p:cSld>
+  <p:clrMapOvr>
+    <a:masterClrMapping/>
+  </p:clrMapOvr>
+</p:sld>
+</file>
+
+<file path=ppt/slides/slide12.xml><?xml version="1.0" encoding="utf-8"?>
+<p:sld xmlns:a="http://schemas.openxmlformats.org/drawingml/2006/main" xmlns:r="http://schemas.openxmlformats.org/officeDocument/2006/relationships" xmlns:p="http://schemas.openxmlformats.org/presentationml/2006/main">
+  <p:cSld>
+    <p:spTree>
+      <p:nvGrpSpPr>
+        <p:cNvPr id="1" name=""/>
+        <p:cNvGrpSpPr/>
+        <p:nvPr/>
+      </p:nvGrpSpPr>
+      <p:grpSpPr>
+        <a:xfrm>
+          <a:off x="0" y="0"/>
+          <a:ext cx="0" cy="0"/>
+          <a:chOff x="0" y="0"/>
+          <a:chExt cx="0" cy="0"/>
+        </a:xfrm>
+      </p:grpSpPr>
+      <p:sp>
+        <p:nvSpPr>
+          <p:cNvPr id="2" name="Title 1">
+            <a:extLst>
+              <a:ext uri="{FF2B5EF4-FFF2-40B4-BE49-F238E27FC236}">
+                <a16:creationId xmlns:a16="http://schemas.microsoft.com/office/drawing/2014/main" id="{8A32E773-3623-2B44-B116-7AD110CA92ED}"/>
+              </a:ext>
+            </a:extLst>
+          </p:cNvPr>
+          <p:cNvSpPr>
+            <a:spLocks noGrp="1"/>
+          </p:cNvSpPr>
+          <p:nvPr>
+            <p:ph type="title"/>
+          </p:nvPr>
+        </p:nvSpPr>
+        <p:spPr>
+          <a:solidFill>
+            <a:srgbClr val="FFC003"/>
+          </a:solidFill>
+        </p:spPr>
+        <p:txBody>
+          <a:bodyPr/>
+          <a:lstStyle/>
+          <a:p>
+            <a:r>
+              <a:rPr lang="en-US" dirty="0">
+                <a:solidFill>
+                  <a:schemeClr val="bg1"/>
+                </a:solidFill>
+              </a:rPr>
+              <a:t>Alpha Diversity</a:t>
+            </a:r>
+          </a:p>
+        </p:txBody>
+      </p:sp>
+      <p:sp>
+        <p:nvSpPr>
+          <p:cNvPr id="3" name="Content Placeholder 2">
+            <a:extLst>
+              <a:ext uri="{FF2B5EF4-FFF2-40B4-BE49-F238E27FC236}">
+                <a16:creationId xmlns:a16="http://schemas.microsoft.com/office/drawing/2014/main" id="{C8B28687-3A56-724D-832B-D6AF3CD1B17E}"/>
+              </a:ext>
+            </a:extLst>
+          </p:cNvPr>
+          <p:cNvSpPr>
+            <a:spLocks noGrp="1"/>
+          </p:cNvSpPr>
+          <p:nvPr>
+            <p:ph idx="1"/>
+          </p:nvPr>
+        </p:nvSpPr>
+        <p:spPr>
+          <a:xfrm>
+            <a:off x="838200" y="5557837"/>
+            <a:ext cx="10515600" cy="619125"/>
+          </a:xfrm>
+        </p:spPr>
+        <p:txBody>
+          <a:bodyPr>
+            <a:normAutofit fontScale="92500" lnSpcReduction="20000"/>
+          </a:bodyPr>
+          <a:lstStyle/>
+          <a:p>
+            <a:pPr marL="0" indent="0" algn="ctr">
+              <a:buNone/>
+            </a:pPr>
+            <a:r>
+              <a:rPr lang="en-US" sz="2400" dirty="0"/>
+              <a:t>Figure : </a:t>
+            </a:r>
+            <a:r>
+              <a:rPr lang="en-GB" sz="2400" dirty="0"/>
+              <a:t>Plots of ASV richness (A) and Shannon Diversity Index (B) for each glacier (richness: t = 2.0202, </a:t>
+            </a:r>
+            <a:r>
+              <a:rPr lang="en-GB" sz="2400" dirty="0" err="1"/>
+              <a:t>df</a:t>
+            </a:r>
+            <a:r>
+              <a:rPr lang="en-GB" sz="2400" dirty="0"/>
+              <a:t> = 32, p=0.0518, Shannon: W = 142, p=0.5808)</a:t>
+            </a:r>
+            <a:endParaRPr lang="en-US" sz="2400" dirty="0"/>
+          </a:p>
+        </p:txBody>
+      </p:sp>
+      <p:pic>
+        <p:nvPicPr>
+          <p:cNvPr id="5" name="Picture 4">
+            <a:extLst>
+              <a:ext uri="{FF2B5EF4-FFF2-40B4-BE49-F238E27FC236}">
+                <a16:creationId xmlns:a16="http://schemas.microsoft.com/office/drawing/2014/main" id="{4FB688A8-5093-E44A-998C-E2EA4D158E52}"/>
+              </a:ext>
+            </a:extLst>
+          </p:cNvPr>
+          <p:cNvPicPr>
+            <a:picLocks noChangeAspect="1"/>
+          </p:cNvPicPr>
+          <p:nvPr/>
+        </p:nvPicPr>
+        <p:blipFill>
+          <a:blip r:embed="rId3"/>
+          <a:stretch>
+            <a:fillRect/>
+          </a:stretch>
+        </p:blipFill>
+        <p:spPr>
+          <a:xfrm>
+            <a:off x="2438400" y="1795463"/>
+            <a:ext cx="7315200" cy="3657600"/>
+          </a:xfrm>
+          <a:prstGeom prst="rect">
+            <a:avLst/>
+          </a:prstGeom>
+        </p:spPr>
+      </p:pic>
+    </p:spTree>
+    <p:extLst>
+      <p:ext uri="{BB962C8B-B14F-4D97-AF65-F5344CB8AC3E}">
+        <p14:creationId xmlns:p14="http://schemas.microsoft.com/office/powerpoint/2010/main" val="3700840866"/>
+      </p:ext>
+    </p:extLst>
+  </p:cSld>
+  <p:clrMapOvr>
+    <a:masterClrMapping/>
+  </p:clrMapOvr>
+</p:sld>
+</file>
+
+<file path=ppt/slides/slide13.xml><?xml version="1.0" encoding="utf-8"?>
+<p:sld xmlns:a="http://schemas.openxmlformats.org/drawingml/2006/main" xmlns:r="http://schemas.openxmlformats.org/officeDocument/2006/relationships" xmlns:p="http://schemas.openxmlformats.org/presentationml/2006/main">
+  <p:cSld>
+    <p:spTree>
+      <p:nvGrpSpPr>
+        <p:cNvPr id="1" name=""/>
+        <p:cNvGrpSpPr/>
+        <p:nvPr/>
+      </p:nvGrpSpPr>
+      <p:grpSpPr>
+        <a:xfrm>
+          <a:off x="0" y="0"/>
+          <a:ext cx="0" cy="0"/>
+          <a:chOff x="0" y="0"/>
+          <a:chExt cx="0" cy="0"/>
+        </a:xfrm>
+      </p:grpSpPr>
+      <p:sp>
+        <p:nvSpPr>
+          <p:cNvPr id="2" name="Title 1">
+            <a:extLst>
+              <a:ext uri="{FF2B5EF4-FFF2-40B4-BE49-F238E27FC236}">
                 <a16:creationId xmlns:a16="http://schemas.microsoft.com/office/drawing/2014/main" id="{B782A0EB-033A-2548-B24B-9258C1B51CB6}"/>
               </a:ext>
             </a:extLst>
@@ -30489,7 +30955,7 @@
 </p:sld>
 </file>
 
-<file path=ppt/slides/slide11.xml><?xml version="1.0" encoding="utf-8"?>
+<file path=ppt/slides/slide14.xml><?xml version="1.0" encoding="utf-8"?>
 <p:sld xmlns:a="http://schemas.openxmlformats.org/drawingml/2006/main" xmlns:r="http://schemas.openxmlformats.org/officeDocument/2006/relationships" xmlns:p="http://schemas.openxmlformats.org/presentationml/2006/main">
   <p:cSld>
     <p:spTree>
@@ -30656,7 +31122,7 @@
 </p:sld>
 </file>
 
-<file path=ppt/slides/slide12.xml><?xml version="1.0" encoding="utf-8"?>
+<file path=ppt/slides/slide15.xml><?xml version="1.0" encoding="utf-8"?>
 <p:sld xmlns:a="http://schemas.openxmlformats.org/drawingml/2006/main" xmlns:r="http://schemas.openxmlformats.org/officeDocument/2006/relationships" xmlns:p="http://schemas.openxmlformats.org/presentationml/2006/main">
   <p:cSld>
     <p:spTree>
@@ -30799,7 +31265,7 @@
 </p:sld>
 </file>
 
-<file path=ppt/slides/slide13.xml><?xml version="1.0" encoding="utf-8"?>
+<file path=ppt/slides/slide16.xml><?xml version="1.0" encoding="utf-8"?>
 <p:sld xmlns:a="http://schemas.openxmlformats.org/drawingml/2006/main" xmlns:r="http://schemas.openxmlformats.org/officeDocument/2006/relationships" xmlns:p="http://schemas.openxmlformats.org/presentationml/2006/main">
   <p:cSld>
     <p:spTree>
@@ -30895,7 +31361,7 @@
 </p:sld>
 </file>
 
-<file path=ppt/slides/slide14.xml><?xml version="1.0" encoding="utf-8"?>
+<file path=ppt/slides/slide17.xml><?xml version="1.0" encoding="utf-8"?>
 <p:sld xmlns:a="http://schemas.openxmlformats.org/drawingml/2006/main" xmlns:r="http://schemas.openxmlformats.org/officeDocument/2006/relationships" xmlns:p="http://schemas.openxmlformats.org/presentationml/2006/main">
   <p:cSld>
     <p:spTree>
@@ -31026,7 +31492,7 @@
 </p:sld>
 </file>
 
-<file path=ppt/slides/slide15.xml><?xml version="1.0" encoding="utf-8"?>
+<file path=ppt/slides/slide18.xml><?xml version="1.0" encoding="utf-8"?>
 <p:sld xmlns:a="http://schemas.openxmlformats.org/drawingml/2006/main" xmlns:r="http://schemas.openxmlformats.org/officeDocument/2006/relationships" xmlns:p="http://schemas.openxmlformats.org/presentationml/2006/main">
   <p:cSld>
     <p:spTree>
@@ -31252,7 +31718,7 @@
 </p:sld>
 </file>
 
-<file path=ppt/slides/slide16.xml><?xml version="1.0" encoding="utf-8"?>
+<file path=ppt/slides/slide19.xml><?xml version="1.0" encoding="utf-8"?>
 <p:sld xmlns:a="http://schemas.openxmlformats.org/drawingml/2006/main" xmlns:r="http://schemas.openxmlformats.org/officeDocument/2006/relationships" xmlns:p="http://schemas.openxmlformats.org/presentationml/2006/main">
   <p:cSld>
     <p:spTree>
@@ -31318,7 +31784,100 @@
 </p:sld>
 </file>
 
-<file path=ppt/slides/slide17.xml><?xml version="1.0" encoding="utf-8"?>
+<file path=ppt/slides/slide2.xml><?xml version="1.0" encoding="utf-8"?>
+<p:sld xmlns:a="http://schemas.openxmlformats.org/drawingml/2006/main" xmlns:r="http://schemas.openxmlformats.org/officeDocument/2006/relationships" xmlns:p="http://schemas.openxmlformats.org/presentationml/2006/main">
+  <p:cSld>
+    <p:spTree>
+      <p:nvGrpSpPr>
+        <p:cNvPr id="1" name=""/>
+        <p:cNvGrpSpPr/>
+        <p:nvPr/>
+      </p:nvGrpSpPr>
+      <p:grpSpPr>
+        <a:xfrm>
+          <a:off x="0" y="0"/>
+          <a:ext cx="0" cy="0"/>
+          <a:chOff x="0" y="0"/>
+          <a:chExt cx="0" cy="0"/>
+        </a:xfrm>
+      </p:grpSpPr>
+      <p:sp>
+        <p:nvSpPr>
+          <p:cNvPr id="2" name="Title 1">
+            <a:extLst>
+              <a:ext uri="{FF2B5EF4-FFF2-40B4-BE49-F238E27FC236}">
+                <a16:creationId xmlns:a16="http://schemas.microsoft.com/office/drawing/2014/main" id="{45EBAA57-4779-4A41-AFFB-BF6247B0B39E}"/>
+              </a:ext>
+            </a:extLst>
+          </p:cNvPr>
+          <p:cNvSpPr>
+            <a:spLocks noGrp="1"/>
+          </p:cNvSpPr>
+          <p:nvPr>
+            <p:ph type="title"/>
+          </p:nvPr>
+        </p:nvSpPr>
+        <p:spPr/>
+        <p:txBody>
+          <a:bodyPr/>
+          <a:lstStyle/>
+          <a:p>
+            <a:r>
+              <a:rPr lang="en-US" dirty="0"/>
+              <a:t>Neutral Theory</a:t>
+            </a:r>
+          </a:p>
+        </p:txBody>
+      </p:sp>
+      <p:sp>
+        <p:nvSpPr>
+          <p:cNvPr id="4" name="TextBox 3">
+            <a:extLst>
+              <a:ext uri="{FF2B5EF4-FFF2-40B4-BE49-F238E27FC236}">
+                <a16:creationId xmlns:a16="http://schemas.microsoft.com/office/drawing/2014/main" id="{DD47A41A-0904-514B-99DB-4E5E573D0747}"/>
+              </a:ext>
+            </a:extLst>
+          </p:cNvPr>
+          <p:cNvSpPr txBox="1"/>
+          <p:nvPr/>
+        </p:nvSpPr>
+        <p:spPr>
+          <a:xfrm>
+            <a:off x="838200" y="6239319"/>
+            <a:ext cx="10787743" cy="369332"/>
+          </a:xfrm>
+          <a:prstGeom prst="rect">
+            <a:avLst/>
+          </a:prstGeom>
+          <a:noFill/>
+        </p:spPr>
+        <p:txBody>
+          <a:bodyPr wrap="square" rtlCol="0">
+            <a:spAutoFit/>
+          </a:bodyPr>
+          <a:lstStyle/>
+          <a:p>
+            <a:r>
+              <a:rPr lang="en-US" dirty="0"/>
+              <a:t>Sloan et al., (2006) Quantifying the roles of immigration and chance in shaping prokaryote community structure</a:t>
+            </a:r>
+          </a:p>
+        </p:txBody>
+      </p:sp>
+    </p:spTree>
+    <p:extLst>
+      <p:ext uri="{BB962C8B-B14F-4D97-AF65-F5344CB8AC3E}">
+        <p14:creationId xmlns:p14="http://schemas.microsoft.com/office/powerpoint/2010/main" val="2186134876"/>
+      </p:ext>
+    </p:extLst>
+  </p:cSld>
+  <p:clrMapOvr>
+    <a:masterClrMapping/>
+  </p:clrMapOvr>
+</p:sld>
+</file>
+
+<file path=ppt/slides/slide20.xml><?xml version="1.0" encoding="utf-8"?>
 <p:sld xmlns:a="http://schemas.openxmlformats.org/drawingml/2006/main" xmlns:r="http://schemas.openxmlformats.org/officeDocument/2006/relationships" xmlns:p="http://schemas.openxmlformats.org/presentationml/2006/main">
   <p:cSld>
     <p:spTree>
@@ -32232,8 +32791,8 @@
           </a:p>
         </p:txBody>
       </p:sp>
-      <mc:AlternateContent xmlns:mc="http://schemas.openxmlformats.org/markup-compatibility/2006">
-        <mc:Choice xmlns:a14="http://schemas.microsoft.com/office/drawing/2010/main" Requires="a14">
+      <mc:AlternateContent xmlns:mc="http://schemas.openxmlformats.org/markup-compatibility/2006" xmlns:a14="http://schemas.microsoft.com/office/drawing/2010/main">
+        <mc:Choice Requires="a14">
           <p:sp>
             <p:nvSpPr>
               <p:cNvPr id="39" name="TextBox 38">
@@ -32339,7 +32898,7 @@
             </p:txBody>
           </p:sp>
         </mc:Choice>
-        <mc:Fallback>
+        <mc:Fallback xmlns="">
           <p:sp>
             <p:nvSpPr>
               <p:cNvPr id="39" name="TextBox 38">
@@ -32432,7 +32991,7 @@
 </p:sld>
 </file>
 
-<file path=ppt/slides/slide18.xml><?xml version="1.0" encoding="utf-8"?>
+<file path=ppt/slides/slide21.xml><?xml version="1.0" encoding="utf-8"?>
 <p:sld xmlns:a="http://schemas.openxmlformats.org/drawingml/2006/main" xmlns:r="http://schemas.openxmlformats.org/officeDocument/2006/relationships" xmlns:p="http://schemas.openxmlformats.org/presentationml/2006/main">
   <p:cSld>
     <p:spTree>
@@ -32791,7 +33350,7 @@
 </p:sld>
 </file>
 
-<file path=ppt/slides/slide19.xml><?xml version="1.0" encoding="utf-8"?>
+<file path=ppt/slides/slide22.xml><?xml version="1.0" encoding="utf-8"?>
 <p:sld xmlns:a="http://schemas.openxmlformats.org/drawingml/2006/main" xmlns:r="http://schemas.openxmlformats.org/officeDocument/2006/relationships" xmlns:p="http://schemas.openxmlformats.org/presentationml/2006/main">
   <p:cSld>
     <p:spTree>
@@ -32887,100 +33446,7 @@
 </p:sld>
 </file>
 
-<file path=ppt/slides/slide2.xml><?xml version="1.0" encoding="utf-8"?>
-<p:sld xmlns:a="http://schemas.openxmlformats.org/drawingml/2006/main" xmlns:r="http://schemas.openxmlformats.org/officeDocument/2006/relationships" xmlns:p="http://schemas.openxmlformats.org/presentationml/2006/main">
-  <p:cSld>
-    <p:spTree>
-      <p:nvGrpSpPr>
-        <p:cNvPr id="1" name=""/>
-        <p:cNvGrpSpPr/>
-        <p:nvPr/>
-      </p:nvGrpSpPr>
-      <p:grpSpPr>
-        <a:xfrm>
-          <a:off x="0" y="0"/>
-          <a:ext cx="0" cy="0"/>
-          <a:chOff x="0" y="0"/>
-          <a:chExt cx="0" cy="0"/>
-        </a:xfrm>
-      </p:grpSpPr>
-      <p:sp>
-        <p:nvSpPr>
-          <p:cNvPr id="2" name="Title 1">
-            <a:extLst>
-              <a:ext uri="{FF2B5EF4-FFF2-40B4-BE49-F238E27FC236}">
-                <a16:creationId xmlns:a16="http://schemas.microsoft.com/office/drawing/2014/main" id="{45EBAA57-4779-4A41-AFFB-BF6247B0B39E}"/>
-              </a:ext>
-            </a:extLst>
-          </p:cNvPr>
-          <p:cNvSpPr>
-            <a:spLocks noGrp="1"/>
-          </p:cNvSpPr>
-          <p:nvPr>
-            <p:ph type="title"/>
-          </p:nvPr>
-        </p:nvSpPr>
-        <p:spPr/>
-        <p:txBody>
-          <a:bodyPr/>
-          <a:lstStyle/>
-          <a:p>
-            <a:r>
-              <a:rPr lang="en-US" dirty="0"/>
-              <a:t>Neutral Theory</a:t>
-            </a:r>
-          </a:p>
-        </p:txBody>
-      </p:sp>
-      <p:sp>
-        <p:nvSpPr>
-          <p:cNvPr id="4" name="TextBox 3">
-            <a:extLst>
-              <a:ext uri="{FF2B5EF4-FFF2-40B4-BE49-F238E27FC236}">
-                <a16:creationId xmlns:a16="http://schemas.microsoft.com/office/drawing/2014/main" id="{DD47A41A-0904-514B-99DB-4E5E573D0747}"/>
-              </a:ext>
-            </a:extLst>
-          </p:cNvPr>
-          <p:cNvSpPr txBox="1"/>
-          <p:nvPr/>
-        </p:nvSpPr>
-        <p:spPr>
-          <a:xfrm>
-            <a:off x="838200" y="6239319"/>
-            <a:ext cx="10787743" cy="369332"/>
-          </a:xfrm>
-          <a:prstGeom prst="rect">
-            <a:avLst/>
-          </a:prstGeom>
-          <a:noFill/>
-        </p:spPr>
-        <p:txBody>
-          <a:bodyPr wrap="square" rtlCol="0">
-            <a:spAutoFit/>
-          </a:bodyPr>
-          <a:lstStyle/>
-          <a:p>
-            <a:r>
-              <a:rPr lang="en-US" dirty="0"/>
-              <a:t>Sloan et al., (2006) Quantifying the roles of immigration and chance in shaping prokaryote community structure</a:t>
-            </a:r>
-          </a:p>
-        </p:txBody>
-      </p:sp>
-    </p:spTree>
-    <p:extLst>
-      <p:ext uri="{BB962C8B-B14F-4D97-AF65-F5344CB8AC3E}">
-        <p14:creationId xmlns:p14="http://schemas.microsoft.com/office/powerpoint/2010/main" val="2186134876"/>
-      </p:ext>
-    </p:extLst>
-  </p:cSld>
-  <p:clrMapOvr>
-    <a:masterClrMapping/>
-  </p:clrMapOvr>
-</p:sld>
-</file>
-
-<file path=ppt/slides/slide20.xml><?xml version="1.0" encoding="utf-8"?>
+<file path=ppt/slides/slide23.xml><?xml version="1.0" encoding="utf-8"?>
 <p:sld xmlns:a="http://schemas.openxmlformats.org/drawingml/2006/main" xmlns:r="http://schemas.openxmlformats.org/officeDocument/2006/relationships" xmlns:p="http://schemas.openxmlformats.org/presentationml/2006/main">
   <p:cSld>
     <p:spTree>
@@ -33144,7 +33610,7 @@
 </p:sld>
 </file>
 
-<file path=ppt/slides/slide21.xml><?xml version="1.0" encoding="utf-8"?>
+<file path=ppt/slides/slide24.xml><?xml version="1.0" encoding="utf-8"?>
 <p:sld xmlns:a="http://schemas.openxmlformats.org/drawingml/2006/main" xmlns:r="http://schemas.openxmlformats.org/officeDocument/2006/relationships" xmlns:p="http://schemas.openxmlformats.org/presentationml/2006/main">
   <p:cSld>
     <p:spTree>
@@ -33242,7 +33708,7 @@
 </p:sld>
 </file>
 
-<file path=ppt/slides/slide22.xml><?xml version="1.0" encoding="utf-8"?>
+<file path=ppt/slides/slide25.xml><?xml version="1.0" encoding="utf-8"?>
 <p:sld xmlns:a="http://schemas.openxmlformats.org/drawingml/2006/main" xmlns:r="http://schemas.openxmlformats.org/officeDocument/2006/relationships" xmlns:p="http://schemas.openxmlformats.org/presentationml/2006/main">
   <p:cSld>
     <p:spTree>
@@ -33337,7 +33803,7 @@
 </p:sld>
 </file>
 
-<file path=ppt/slides/slide23.xml><?xml version="1.0" encoding="utf-8"?>
+<file path=ppt/slides/slide26.xml><?xml version="1.0" encoding="utf-8"?>
 <p:sld xmlns:a="http://schemas.openxmlformats.org/drawingml/2006/main" xmlns:r="http://schemas.openxmlformats.org/officeDocument/2006/relationships" xmlns:p="http://schemas.openxmlformats.org/presentationml/2006/main">
   <p:cSld>
     <p:spTree>
@@ -33433,7 +33899,7 @@
 </p:sld>
 </file>
 
-<file path=ppt/slides/slide24.xml><?xml version="1.0" encoding="utf-8"?>
+<file path=ppt/slides/slide27.xml><?xml version="1.0" encoding="utf-8"?>
 <p:sld xmlns:a="http://schemas.openxmlformats.org/drawingml/2006/main" xmlns:r="http://schemas.openxmlformats.org/officeDocument/2006/relationships" xmlns:p="http://schemas.openxmlformats.org/presentationml/2006/main">
   <p:cSld>
     <p:spTree>
@@ -33529,7 +33995,7 @@
 </p:sld>
 </file>
 
-<file path=ppt/slides/slide25.xml><?xml version="1.0" encoding="utf-8"?>
+<file path=ppt/slides/slide28.xml><?xml version="1.0" encoding="utf-8"?>
 <p:sld xmlns:a="http://schemas.openxmlformats.org/drawingml/2006/main" xmlns:r="http://schemas.openxmlformats.org/officeDocument/2006/relationships" xmlns:p="http://schemas.openxmlformats.org/presentationml/2006/main">
   <p:cSld>
     <p:spTree>
@@ -33595,7 +34061,7 @@
 </p:sld>
 </file>
 
-<file path=ppt/slides/slide26.xml><?xml version="1.0" encoding="utf-8"?>
+<file path=ppt/slides/slide29.xml><?xml version="1.0" encoding="utf-8"?>
 <p:sld xmlns:a="http://schemas.openxmlformats.org/drawingml/2006/main" xmlns:r="http://schemas.openxmlformats.org/officeDocument/2006/relationships" xmlns:p="http://schemas.openxmlformats.org/presentationml/2006/main">
   <p:cSld>
     <p:spTree>
@@ -33701,296 +34167,6 @@
     <p:extLst>
       <p:ext uri="{BB962C8B-B14F-4D97-AF65-F5344CB8AC3E}">
         <p14:creationId xmlns:p14="http://schemas.microsoft.com/office/powerpoint/2010/main" val="3748687434"/>
-      </p:ext>
-    </p:extLst>
-  </p:cSld>
-  <p:clrMapOvr>
-    <a:masterClrMapping/>
-  </p:clrMapOvr>
-</p:sld>
-</file>
-
-<file path=ppt/slides/slide27.xml><?xml version="1.0" encoding="utf-8"?>
-<p:sld xmlns:a="http://schemas.openxmlformats.org/drawingml/2006/main" xmlns:r="http://schemas.openxmlformats.org/officeDocument/2006/relationships" xmlns:p="http://schemas.openxmlformats.org/presentationml/2006/main">
-  <p:cSld>
-    <p:spTree>
-      <p:nvGrpSpPr>
-        <p:cNvPr id="1" name=""/>
-        <p:cNvGrpSpPr/>
-        <p:nvPr/>
-      </p:nvGrpSpPr>
-      <p:grpSpPr>
-        <a:xfrm>
-          <a:off x="0" y="0"/>
-          <a:ext cx="0" cy="0"/>
-          <a:chOff x="0" y="0"/>
-          <a:chExt cx="0" cy="0"/>
-        </a:xfrm>
-      </p:grpSpPr>
-      <p:sp>
-        <p:nvSpPr>
-          <p:cNvPr id="2" name="Title 1">
-            <a:extLst>
-              <a:ext uri="{FF2B5EF4-FFF2-40B4-BE49-F238E27FC236}">
-                <a16:creationId xmlns:a16="http://schemas.microsoft.com/office/drawing/2014/main" id="{147D2BF3-8D20-3347-8C3A-FC5C22DAA765}"/>
-              </a:ext>
-            </a:extLst>
-          </p:cNvPr>
-          <p:cNvSpPr>
-            <a:spLocks noGrp="1"/>
-          </p:cNvSpPr>
-          <p:nvPr>
-            <p:ph type="title"/>
-          </p:nvPr>
-        </p:nvSpPr>
-        <p:spPr>
-          <a:solidFill>
-            <a:srgbClr val="5C9BD5"/>
-          </a:solidFill>
-          <a:ln>
-            <a:solidFill>
-              <a:schemeClr val="accent1"/>
-            </a:solidFill>
-          </a:ln>
-        </p:spPr>
-        <p:txBody>
-          <a:bodyPr/>
-          <a:lstStyle/>
-          <a:p>
-            <a:r>
-              <a:rPr lang="en-US" dirty="0"/>
-              <a:t>Results</a:t>
-            </a:r>
-          </a:p>
-        </p:txBody>
-      </p:sp>
-      <p:sp>
-        <p:nvSpPr>
-          <p:cNvPr id="3" name="Content Placeholder 2">
-            <a:extLst>
-              <a:ext uri="{FF2B5EF4-FFF2-40B4-BE49-F238E27FC236}">
-                <a16:creationId xmlns:a16="http://schemas.microsoft.com/office/drawing/2014/main" id="{F9534A9C-B446-AB47-AFCB-FC722EBB3FD3}"/>
-              </a:ext>
-            </a:extLst>
-          </p:cNvPr>
-          <p:cNvSpPr>
-            <a:spLocks noGrp="1"/>
-          </p:cNvSpPr>
-          <p:nvPr>
-            <p:ph idx="1"/>
-          </p:nvPr>
-        </p:nvSpPr>
-        <p:spPr/>
-        <p:txBody>
-          <a:bodyPr/>
-          <a:lstStyle/>
-          <a:p>
-            <a:endParaRPr lang="en-US"/>
-          </a:p>
-        </p:txBody>
-      </p:sp>
-    </p:spTree>
-    <p:extLst>
-      <p:ext uri="{BB962C8B-B14F-4D97-AF65-F5344CB8AC3E}">
-        <p14:creationId xmlns:p14="http://schemas.microsoft.com/office/powerpoint/2010/main" val="3629005695"/>
-      </p:ext>
-    </p:extLst>
-  </p:cSld>
-  <p:clrMapOvr>
-    <a:masterClrMapping/>
-  </p:clrMapOvr>
-</p:sld>
-</file>
-
-<file path=ppt/slides/slide28.xml><?xml version="1.0" encoding="utf-8"?>
-<p:sld xmlns:a="http://schemas.openxmlformats.org/drawingml/2006/main" xmlns:r="http://schemas.openxmlformats.org/officeDocument/2006/relationships" xmlns:p="http://schemas.openxmlformats.org/presentationml/2006/main">
-  <p:cSld>
-    <p:spTree>
-      <p:nvGrpSpPr>
-        <p:cNvPr id="1" name=""/>
-        <p:cNvGrpSpPr/>
-        <p:nvPr/>
-      </p:nvGrpSpPr>
-      <p:grpSpPr>
-        <a:xfrm>
-          <a:off x="0" y="0"/>
-          <a:ext cx="0" cy="0"/>
-          <a:chOff x="0" y="0"/>
-          <a:chExt cx="0" cy="0"/>
-        </a:xfrm>
-      </p:grpSpPr>
-      <p:sp>
-        <p:nvSpPr>
-          <p:cNvPr id="2" name="Title 1">
-            <a:extLst>
-              <a:ext uri="{FF2B5EF4-FFF2-40B4-BE49-F238E27FC236}">
-                <a16:creationId xmlns:a16="http://schemas.microsoft.com/office/drawing/2014/main" id="{174D7E04-7C38-FB49-A0A0-EF5E49EDA455}"/>
-              </a:ext>
-            </a:extLst>
-          </p:cNvPr>
-          <p:cNvSpPr>
-            <a:spLocks noGrp="1"/>
-          </p:cNvSpPr>
-          <p:nvPr>
-            <p:ph type="title"/>
-          </p:nvPr>
-        </p:nvSpPr>
-        <p:spPr>
-          <a:solidFill>
-            <a:srgbClr val="5C9BD5"/>
-          </a:solidFill>
-        </p:spPr>
-        <p:txBody>
-          <a:bodyPr>
-            <a:noAutofit/>
-          </a:bodyPr>
-          <a:lstStyle/>
-          <a:p>
-            <a:r>
-              <a:rPr lang="en-GB" sz="2800" b="1" dirty="0">
-                <a:solidFill>
-                  <a:schemeClr val="bg1"/>
-                </a:solidFill>
-              </a:rPr>
-              <a:t>Hu et al., (2017) Strong impact of anthropogenic contamination on the co‐occurrence patterns of a riverine microbial community</a:t>
-            </a:r>
-            <a:br>
-              <a:rPr lang="en-GB" sz="2800" b="1" dirty="0">
-                <a:solidFill>
-                  <a:schemeClr val="bg1"/>
-                </a:solidFill>
-              </a:rPr>
-            </a:br>
-            <a:endParaRPr lang="en-US" sz="2800" dirty="0">
-              <a:solidFill>
-                <a:schemeClr val="bg1"/>
-              </a:solidFill>
-            </a:endParaRPr>
-          </a:p>
-        </p:txBody>
-      </p:sp>
-    </p:spTree>
-    <p:extLst>
-      <p:ext uri="{BB962C8B-B14F-4D97-AF65-F5344CB8AC3E}">
-        <p14:creationId xmlns:p14="http://schemas.microsoft.com/office/powerpoint/2010/main" val="2136607666"/>
-      </p:ext>
-    </p:extLst>
-  </p:cSld>
-  <p:clrMapOvr>
-    <a:masterClrMapping/>
-  </p:clrMapOvr>
-</p:sld>
-</file>
-
-<file path=ppt/slides/slide29.xml><?xml version="1.0" encoding="utf-8"?>
-<p:sld xmlns:a="http://schemas.openxmlformats.org/drawingml/2006/main" xmlns:r="http://schemas.openxmlformats.org/officeDocument/2006/relationships" xmlns:p="http://schemas.openxmlformats.org/presentationml/2006/main">
-  <p:cSld>
-    <p:spTree>
-      <p:nvGrpSpPr>
-        <p:cNvPr id="1" name=""/>
-        <p:cNvGrpSpPr/>
-        <p:nvPr/>
-      </p:nvGrpSpPr>
-      <p:grpSpPr>
-        <a:xfrm>
-          <a:off x="0" y="0"/>
-          <a:ext cx="0" cy="0"/>
-          <a:chOff x="0" y="0"/>
-          <a:chExt cx="0" cy="0"/>
-        </a:xfrm>
-      </p:grpSpPr>
-      <p:sp>
-        <p:nvSpPr>
-          <p:cNvPr id="2" name="Title 1">
-            <a:extLst>
-              <a:ext uri="{FF2B5EF4-FFF2-40B4-BE49-F238E27FC236}">
-                <a16:creationId xmlns:a16="http://schemas.microsoft.com/office/drawing/2014/main" id="{4C2DA027-B72B-4144-A731-E9B94EB5EDDD}"/>
-              </a:ext>
-            </a:extLst>
-          </p:cNvPr>
-          <p:cNvSpPr>
-            <a:spLocks noGrp="1"/>
-          </p:cNvSpPr>
-          <p:nvPr>
-            <p:ph type="title"/>
-          </p:nvPr>
-        </p:nvSpPr>
-        <p:spPr/>
-        <p:txBody>
-          <a:bodyPr/>
-          <a:lstStyle/>
-          <a:p>
-            <a:endParaRPr lang="en-US"/>
-          </a:p>
-        </p:txBody>
-      </p:sp>
-      <p:sp>
-        <p:nvSpPr>
-          <p:cNvPr id="3" name="Content Placeholder 2">
-            <a:extLst>
-              <a:ext uri="{FF2B5EF4-FFF2-40B4-BE49-F238E27FC236}">
-                <a16:creationId xmlns:a16="http://schemas.microsoft.com/office/drawing/2014/main" id="{9F9B51A7-07A9-CA41-AA95-F674E4BEFDE9}"/>
-              </a:ext>
-            </a:extLst>
-          </p:cNvPr>
-          <p:cNvSpPr>
-            <a:spLocks noGrp="1"/>
-          </p:cNvSpPr>
-          <p:nvPr>
-            <p:ph idx="1"/>
-          </p:nvPr>
-        </p:nvSpPr>
-        <p:spPr/>
-        <p:txBody>
-          <a:bodyPr/>
-          <a:lstStyle/>
-          <a:p>
-            <a:pPr marL="514350" indent="-514350">
-              <a:buFont typeface="+mj-lt"/>
-              <a:buAutoNum type="arabicPeriod"/>
-            </a:pPr>
-            <a:r>
-              <a:rPr lang="en-US" dirty="0"/>
-              <a:t>Transpose </a:t>
-            </a:r>
-            <a:r>
-              <a:rPr lang="en-US" dirty="0" err="1"/>
-              <a:t>asv</a:t>
-            </a:r>
-            <a:r>
-              <a:rPr lang="en-US" dirty="0"/>
-              <a:t> table (</a:t>
-            </a:r>
-            <a:r>
-              <a:rPr lang="en-US" dirty="0" err="1"/>
-              <a:t>asv</a:t>
-            </a:r>
-            <a:r>
-              <a:rPr lang="en-US" dirty="0"/>
-              <a:t> = rows, samples = columns) and compute a matrix of Spearman’s rho rank correlation coefficients for all possible pairs of columns (</a:t>
-            </a:r>
-            <a:r>
-              <a:rPr lang="en-US" dirty="0" err="1"/>
-              <a:t>asvs</a:t>
-            </a:r>
-            <a:r>
-              <a:rPr lang="en-US" dirty="0"/>
-              <a:t>).</a:t>
-            </a:r>
-          </a:p>
-          <a:p>
-            <a:pPr marL="514350" indent="-514350">
-              <a:buFont typeface="+mj-lt"/>
-              <a:buAutoNum type="arabicPeriod"/>
-            </a:pPr>
-            <a:endParaRPr lang="en-US" dirty="0"/>
-          </a:p>
-        </p:txBody>
-      </p:sp>
-    </p:spTree>
-    <p:extLst>
-      <p:ext uri="{BB962C8B-B14F-4D97-AF65-F5344CB8AC3E}">
-        <p14:creationId xmlns:p14="http://schemas.microsoft.com/office/powerpoint/2010/main" val="1057470918"/>
       </p:ext>
     </p:extLst>
   </p:cSld>
@@ -34100,6 +34276,296 @@
     <p:extLst>
       <p:ext uri="{BB962C8B-B14F-4D97-AF65-F5344CB8AC3E}">
         <p14:creationId xmlns:p14="http://schemas.microsoft.com/office/powerpoint/2010/main" val="3966638715"/>
+      </p:ext>
+    </p:extLst>
+  </p:cSld>
+  <p:clrMapOvr>
+    <a:masterClrMapping/>
+  </p:clrMapOvr>
+</p:sld>
+</file>
+
+<file path=ppt/slides/slide30.xml><?xml version="1.0" encoding="utf-8"?>
+<p:sld xmlns:a="http://schemas.openxmlformats.org/drawingml/2006/main" xmlns:r="http://schemas.openxmlformats.org/officeDocument/2006/relationships" xmlns:p="http://schemas.openxmlformats.org/presentationml/2006/main">
+  <p:cSld>
+    <p:spTree>
+      <p:nvGrpSpPr>
+        <p:cNvPr id="1" name=""/>
+        <p:cNvGrpSpPr/>
+        <p:nvPr/>
+      </p:nvGrpSpPr>
+      <p:grpSpPr>
+        <a:xfrm>
+          <a:off x="0" y="0"/>
+          <a:ext cx="0" cy="0"/>
+          <a:chOff x="0" y="0"/>
+          <a:chExt cx="0" cy="0"/>
+        </a:xfrm>
+      </p:grpSpPr>
+      <p:sp>
+        <p:nvSpPr>
+          <p:cNvPr id="2" name="Title 1">
+            <a:extLst>
+              <a:ext uri="{FF2B5EF4-FFF2-40B4-BE49-F238E27FC236}">
+                <a16:creationId xmlns:a16="http://schemas.microsoft.com/office/drawing/2014/main" id="{147D2BF3-8D20-3347-8C3A-FC5C22DAA765}"/>
+              </a:ext>
+            </a:extLst>
+          </p:cNvPr>
+          <p:cNvSpPr>
+            <a:spLocks noGrp="1"/>
+          </p:cNvSpPr>
+          <p:nvPr>
+            <p:ph type="title"/>
+          </p:nvPr>
+        </p:nvSpPr>
+        <p:spPr>
+          <a:solidFill>
+            <a:srgbClr val="5C9BD5"/>
+          </a:solidFill>
+          <a:ln>
+            <a:solidFill>
+              <a:schemeClr val="accent1"/>
+            </a:solidFill>
+          </a:ln>
+        </p:spPr>
+        <p:txBody>
+          <a:bodyPr/>
+          <a:lstStyle/>
+          <a:p>
+            <a:r>
+              <a:rPr lang="en-US" dirty="0"/>
+              <a:t>Results</a:t>
+            </a:r>
+          </a:p>
+        </p:txBody>
+      </p:sp>
+      <p:sp>
+        <p:nvSpPr>
+          <p:cNvPr id="3" name="Content Placeholder 2">
+            <a:extLst>
+              <a:ext uri="{FF2B5EF4-FFF2-40B4-BE49-F238E27FC236}">
+                <a16:creationId xmlns:a16="http://schemas.microsoft.com/office/drawing/2014/main" id="{F9534A9C-B446-AB47-AFCB-FC722EBB3FD3}"/>
+              </a:ext>
+            </a:extLst>
+          </p:cNvPr>
+          <p:cNvSpPr>
+            <a:spLocks noGrp="1"/>
+          </p:cNvSpPr>
+          <p:nvPr>
+            <p:ph idx="1"/>
+          </p:nvPr>
+        </p:nvSpPr>
+        <p:spPr/>
+        <p:txBody>
+          <a:bodyPr/>
+          <a:lstStyle/>
+          <a:p>
+            <a:endParaRPr lang="en-US"/>
+          </a:p>
+        </p:txBody>
+      </p:sp>
+    </p:spTree>
+    <p:extLst>
+      <p:ext uri="{BB962C8B-B14F-4D97-AF65-F5344CB8AC3E}">
+        <p14:creationId xmlns:p14="http://schemas.microsoft.com/office/powerpoint/2010/main" val="3629005695"/>
+      </p:ext>
+    </p:extLst>
+  </p:cSld>
+  <p:clrMapOvr>
+    <a:masterClrMapping/>
+  </p:clrMapOvr>
+</p:sld>
+</file>
+
+<file path=ppt/slides/slide31.xml><?xml version="1.0" encoding="utf-8"?>
+<p:sld xmlns:a="http://schemas.openxmlformats.org/drawingml/2006/main" xmlns:r="http://schemas.openxmlformats.org/officeDocument/2006/relationships" xmlns:p="http://schemas.openxmlformats.org/presentationml/2006/main">
+  <p:cSld>
+    <p:spTree>
+      <p:nvGrpSpPr>
+        <p:cNvPr id="1" name=""/>
+        <p:cNvGrpSpPr/>
+        <p:nvPr/>
+      </p:nvGrpSpPr>
+      <p:grpSpPr>
+        <a:xfrm>
+          <a:off x="0" y="0"/>
+          <a:ext cx="0" cy="0"/>
+          <a:chOff x="0" y="0"/>
+          <a:chExt cx="0" cy="0"/>
+        </a:xfrm>
+      </p:grpSpPr>
+      <p:sp>
+        <p:nvSpPr>
+          <p:cNvPr id="2" name="Title 1">
+            <a:extLst>
+              <a:ext uri="{FF2B5EF4-FFF2-40B4-BE49-F238E27FC236}">
+                <a16:creationId xmlns:a16="http://schemas.microsoft.com/office/drawing/2014/main" id="{174D7E04-7C38-FB49-A0A0-EF5E49EDA455}"/>
+              </a:ext>
+            </a:extLst>
+          </p:cNvPr>
+          <p:cNvSpPr>
+            <a:spLocks noGrp="1"/>
+          </p:cNvSpPr>
+          <p:nvPr>
+            <p:ph type="title"/>
+          </p:nvPr>
+        </p:nvSpPr>
+        <p:spPr>
+          <a:solidFill>
+            <a:srgbClr val="5C9BD5"/>
+          </a:solidFill>
+        </p:spPr>
+        <p:txBody>
+          <a:bodyPr>
+            <a:noAutofit/>
+          </a:bodyPr>
+          <a:lstStyle/>
+          <a:p>
+            <a:r>
+              <a:rPr lang="en-GB" sz="2800" b="1" dirty="0">
+                <a:solidFill>
+                  <a:schemeClr val="bg1"/>
+                </a:solidFill>
+              </a:rPr>
+              <a:t>Hu et al., (2017) Strong impact of anthropogenic contamination on the co‐occurrence patterns of a riverine microbial community</a:t>
+            </a:r>
+            <a:br>
+              <a:rPr lang="en-GB" sz="2800" b="1" dirty="0">
+                <a:solidFill>
+                  <a:schemeClr val="bg1"/>
+                </a:solidFill>
+              </a:rPr>
+            </a:br>
+            <a:endParaRPr lang="en-US" sz="2800" dirty="0">
+              <a:solidFill>
+                <a:schemeClr val="bg1"/>
+              </a:solidFill>
+            </a:endParaRPr>
+          </a:p>
+        </p:txBody>
+      </p:sp>
+    </p:spTree>
+    <p:extLst>
+      <p:ext uri="{BB962C8B-B14F-4D97-AF65-F5344CB8AC3E}">
+        <p14:creationId xmlns:p14="http://schemas.microsoft.com/office/powerpoint/2010/main" val="2136607666"/>
+      </p:ext>
+    </p:extLst>
+  </p:cSld>
+  <p:clrMapOvr>
+    <a:masterClrMapping/>
+  </p:clrMapOvr>
+</p:sld>
+</file>
+
+<file path=ppt/slides/slide32.xml><?xml version="1.0" encoding="utf-8"?>
+<p:sld xmlns:a="http://schemas.openxmlformats.org/drawingml/2006/main" xmlns:r="http://schemas.openxmlformats.org/officeDocument/2006/relationships" xmlns:p="http://schemas.openxmlformats.org/presentationml/2006/main">
+  <p:cSld>
+    <p:spTree>
+      <p:nvGrpSpPr>
+        <p:cNvPr id="1" name=""/>
+        <p:cNvGrpSpPr/>
+        <p:nvPr/>
+      </p:nvGrpSpPr>
+      <p:grpSpPr>
+        <a:xfrm>
+          <a:off x="0" y="0"/>
+          <a:ext cx="0" cy="0"/>
+          <a:chOff x="0" y="0"/>
+          <a:chExt cx="0" cy="0"/>
+        </a:xfrm>
+      </p:grpSpPr>
+      <p:sp>
+        <p:nvSpPr>
+          <p:cNvPr id="2" name="Title 1">
+            <a:extLst>
+              <a:ext uri="{FF2B5EF4-FFF2-40B4-BE49-F238E27FC236}">
+                <a16:creationId xmlns:a16="http://schemas.microsoft.com/office/drawing/2014/main" id="{4C2DA027-B72B-4144-A731-E9B94EB5EDDD}"/>
+              </a:ext>
+            </a:extLst>
+          </p:cNvPr>
+          <p:cNvSpPr>
+            <a:spLocks noGrp="1"/>
+          </p:cNvSpPr>
+          <p:nvPr>
+            <p:ph type="title"/>
+          </p:nvPr>
+        </p:nvSpPr>
+        <p:spPr/>
+        <p:txBody>
+          <a:bodyPr/>
+          <a:lstStyle/>
+          <a:p>
+            <a:endParaRPr lang="en-US"/>
+          </a:p>
+        </p:txBody>
+      </p:sp>
+      <p:sp>
+        <p:nvSpPr>
+          <p:cNvPr id="3" name="Content Placeholder 2">
+            <a:extLst>
+              <a:ext uri="{FF2B5EF4-FFF2-40B4-BE49-F238E27FC236}">
+                <a16:creationId xmlns:a16="http://schemas.microsoft.com/office/drawing/2014/main" id="{9F9B51A7-07A9-CA41-AA95-F674E4BEFDE9}"/>
+              </a:ext>
+            </a:extLst>
+          </p:cNvPr>
+          <p:cNvSpPr>
+            <a:spLocks noGrp="1"/>
+          </p:cNvSpPr>
+          <p:nvPr>
+            <p:ph idx="1"/>
+          </p:nvPr>
+        </p:nvSpPr>
+        <p:spPr/>
+        <p:txBody>
+          <a:bodyPr/>
+          <a:lstStyle/>
+          <a:p>
+            <a:pPr marL="514350" indent="-514350">
+              <a:buFont typeface="+mj-lt"/>
+              <a:buAutoNum type="arabicPeriod"/>
+            </a:pPr>
+            <a:r>
+              <a:rPr lang="en-US" dirty="0"/>
+              <a:t>Transpose </a:t>
+            </a:r>
+            <a:r>
+              <a:rPr lang="en-US" dirty="0" err="1"/>
+              <a:t>asv</a:t>
+            </a:r>
+            <a:r>
+              <a:rPr lang="en-US" dirty="0"/>
+              <a:t> table (</a:t>
+            </a:r>
+            <a:r>
+              <a:rPr lang="en-US" dirty="0" err="1"/>
+              <a:t>asv</a:t>
+            </a:r>
+            <a:r>
+              <a:rPr lang="en-US" dirty="0"/>
+              <a:t> = rows, samples = columns) and compute a matrix of Spearman’s rho rank correlation coefficients for all possible pairs of columns (</a:t>
+            </a:r>
+            <a:r>
+              <a:rPr lang="en-US" dirty="0" err="1"/>
+              <a:t>asvs</a:t>
+            </a:r>
+            <a:r>
+              <a:rPr lang="en-US" dirty="0"/>
+              <a:t>).</a:t>
+            </a:r>
+          </a:p>
+          <a:p>
+            <a:pPr marL="514350" indent="-514350">
+              <a:buFont typeface="+mj-lt"/>
+              <a:buAutoNum type="arabicPeriod"/>
+            </a:pPr>
+            <a:endParaRPr lang="en-US" dirty="0"/>
+          </a:p>
+        </p:txBody>
+      </p:sp>
+    </p:spTree>
+    <p:extLst>
+      <p:ext uri="{BB962C8B-B14F-4D97-AF65-F5344CB8AC3E}">
+        <p14:creationId xmlns:p14="http://schemas.microsoft.com/office/powerpoint/2010/main" val="1057470918"/>
       </p:ext>
     </p:extLst>
   </p:cSld>
@@ -34460,7 +34926,7 @@
           <p:nvPr>
             <p:extLst>
               <p:ext uri="{D42A27DB-BD31-4B8C-83A1-F6EECF244321}">
-                <p14:modId xmlns:p14="http://schemas.microsoft.com/office/powerpoint/2010/main" val="2036473356"/>
+                <p14:modId xmlns:p14="http://schemas.microsoft.com/office/powerpoint/2010/main" val="1814273274"/>
               </p:ext>
             </p:extLst>
           </p:nvPr>
@@ -34510,7 +34976,7 @@
           <p:cNvPr id="2" name="Title 1">
             <a:extLst>
               <a:ext uri="{FF2B5EF4-FFF2-40B4-BE49-F238E27FC236}">
-                <a16:creationId xmlns:a16="http://schemas.microsoft.com/office/drawing/2014/main" id="{F8883892-3D96-014B-BA22-D3A4750E524A}"/>
+                <a16:creationId xmlns:a16="http://schemas.microsoft.com/office/drawing/2014/main" id="{E54A1066-9CC5-E14D-8897-07704940C8FB}"/>
               </a:ext>
             </a:extLst>
           </p:cNvPr>
@@ -34521,22 +34987,14 @@
             <p:ph type="title"/>
           </p:nvPr>
         </p:nvSpPr>
-        <p:spPr>
-          <a:solidFill>
-            <a:srgbClr val="FFC003"/>
-          </a:solidFill>
-        </p:spPr>
+        <p:spPr/>
         <p:txBody>
           <a:bodyPr/>
           <a:lstStyle/>
           <a:p>
             <a:r>
-              <a:rPr lang="en-US" dirty="0">
-                <a:solidFill>
-                  <a:schemeClr val="bg1"/>
-                </a:solidFill>
-              </a:rPr>
-              <a:t>Multivariate Analysis</a:t>
+              <a:rPr lang="en-US" dirty="0"/>
+              <a:t>Abundant and rare taxa</a:t>
             </a:r>
           </a:p>
         </p:txBody>
@@ -34546,7 +35004,7 @@
           <p:cNvPr id="3" name="Content Placeholder 2">
             <a:extLst>
               <a:ext uri="{FF2B5EF4-FFF2-40B4-BE49-F238E27FC236}">
-                <a16:creationId xmlns:a16="http://schemas.microsoft.com/office/drawing/2014/main" id="{057D77B9-9D78-E74A-8AAE-82071815FD34}"/>
+                <a16:creationId xmlns:a16="http://schemas.microsoft.com/office/drawing/2014/main" id="{77E46C54-EBE1-BB4E-BACB-6A3C6120FCEF}"/>
               </a:ext>
             </a:extLst>
           </p:cNvPr>
@@ -34557,48 +35015,113 @@
             <p:ph idx="1"/>
           </p:nvPr>
         </p:nvSpPr>
-        <p:spPr/>
+        <p:spPr>
+          <a:xfrm>
+            <a:off x="838200" y="1825625"/>
+            <a:ext cx="10515600" cy="3973009"/>
+          </a:xfrm>
+        </p:spPr>
         <p:txBody>
-          <a:bodyPr>
-            <a:normAutofit/>
+          <a:bodyPr/>
+          <a:lstStyle/>
+          <a:p>
+            <a:r>
+              <a:rPr lang="en-US" dirty="0"/>
+              <a:t>Rarefied </a:t>
+            </a:r>
+            <a:r>
+              <a:rPr lang="en-US" dirty="0" err="1"/>
+              <a:t>phyloseq</a:t>
+            </a:r>
+            <a:r>
+              <a:rPr lang="en-US" dirty="0"/>
+              <a:t> object to even sampling depth</a:t>
+            </a:r>
+          </a:p>
+          <a:p>
+            <a:r>
+              <a:rPr lang="en-US" dirty="0"/>
+              <a:t>Get local (within sample) relative abundances</a:t>
+            </a:r>
+          </a:p>
+          <a:p>
+            <a:r>
+              <a:rPr lang="en-US" dirty="0"/>
+              <a:t>Find the regional (between sample) relative abundances = mean of local relative abundances </a:t>
+            </a:r>
+          </a:p>
+          <a:p>
+            <a:r>
+              <a:rPr lang="en-US" dirty="0"/>
+              <a:t>Locally abundant taxa &gt; 1% relative abundance</a:t>
+            </a:r>
+          </a:p>
+          <a:p>
+            <a:r>
+              <a:rPr lang="en-US" dirty="0"/>
+              <a:t>Locally rare taxa &lt; 0.01% relative abundance</a:t>
+            </a:r>
+          </a:p>
+          <a:p>
+            <a:r>
+              <a:rPr lang="en-US" dirty="0"/>
+              <a:t>Regionally abundant taxa &gt; 0.1% mean relative abundance</a:t>
+            </a:r>
+          </a:p>
+          <a:p>
+            <a:r>
+              <a:rPr lang="en-US" dirty="0"/>
+              <a:t>Regionally rare taxa &lt; 0.01% mean relative abundance</a:t>
+            </a:r>
+          </a:p>
+        </p:txBody>
+      </p:sp>
+      <p:sp>
+        <p:nvSpPr>
+          <p:cNvPr id="4" name="TextBox 3">
+            <a:extLst>
+              <a:ext uri="{FF2B5EF4-FFF2-40B4-BE49-F238E27FC236}">
+                <a16:creationId xmlns:a16="http://schemas.microsoft.com/office/drawing/2014/main" id="{35487150-8A79-7B40-A578-3DD8B0E30FDC}"/>
+              </a:ext>
+            </a:extLst>
+          </p:cNvPr>
+          <p:cNvSpPr txBox="1"/>
+          <p:nvPr/>
+        </p:nvSpPr>
+        <p:spPr>
+          <a:xfrm>
+            <a:off x="602166" y="6021659"/>
+            <a:ext cx="10751634" cy="923330"/>
+          </a:xfrm>
+          <a:prstGeom prst="rect">
+            <a:avLst/>
+          </a:prstGeom>
+          <a:noFill/>
+        </p:spPr>
+        <p:txBody>
+          <a:bodyPr wrap="square" rtlCol="0">
+            <a:spAutoFit/>
           </a:bodyPr>
           <a:lstStyle/>
           <a:p>
-            <a:pPr marL="742950" indent="-742950">
-              <a:buFont typeface="+mj-lt"/>
-              <a:buAutoNum type="arabicPeriod"/>
-            </a:pPr>
-            <a:r>
-              <a:rPr lang="en-US" sz="4000" dirty="0"/>
-              <a:t>Alpha Diversity </a:t>
-            </a:r>
-          </a:p>
-          <a:p>
-            <a:pPr marL="742950" indent="-742950">
-              <a:buFont typeface="+mj-lt"/>
-              <a:buAutoNum type="arabicPeriod"/>
-            </a:pPr>
-            <a:r>
-              <a:rPr lang="en-US" sz="4000" dirty="0"/>
-              <a:t>Beta Diversity &amp; Ordination</a:t>
-            </a:r>
-          </a:p>
-          <a:p>
-            <a:pPr marL="742950" indent="-742950">
-              <a:buFont typeface="+mj-lt"/>
-              <a:buAutoNum type="arabicPeriod"/>
-            </a:pPr>
-            <a:r>
-              <a:rPr lang="en-US" sz="4000" dirty="0"/>
-              <a:t>ISAR and DDR</a:t>
-            </a:r>
+            <a:r>
+              <a:rPr lang="en-US" dirty="0"/>
+              <a:t>Li et al., (2021) </a:t>
+            </a:r>
+            <a:r>
+              <a:rPr lang="en-GB" dirty="0"/>
+              <a:t>Active bacterial and archaeal communities in coastal sediments: Biogeography pattern, assembly process and co-occurrence relationship</a:t>
+            </a:r>
+          </a:p>
+          <a:p>
+            <a:endParaRPr lang="en-US" dirty="0"/>
           </a:p>
         </p:txBody>
       </p:sp>
     </p:spTree>
     <p:extLst>
       <p:ext uri="{BB962C8B-B14F-4D97-AF65-F5344CB8AC3E}">
-        <p14:creationId xmlns:p14="http://schemas.microsoft.com/office/powerpoint/2010/main" val="542213217"/>
+        <p14:creationId xmlns:p14="http://schemas.microsoft.com/office/powerpoint/2010/main" val="901630170"/>
       </p:ext>
     </p:extLst>
   </p:cSld>
@@ -34630,7 +35153,7 @@
           <p:cNvPr id="2" name="Title 1">
             <a:extLst>
               <a:ext uri="{FF2B5EF4-FFF2-40B4-BE49-F238E27FC236}">
-                <a16:creationId xmlns:a16="http://schemas.microsoft.com/office/drawing/2014/main" id="{8A32E773-3623-2B44-B116-7AD110CA92ED}"/>
+                <a16:creationId xmlns:a16="http://schemas.microsoft.com/office/drawing/2014/main" id="{AAACA58D-E097-5841-8D42-79DD96D96DD8}"/>
               </a:ext>
             </a:extLst>
           </p:cNvPr>
@@ -34641,83 +35164,132 @@
             <p:ph type="title"/>
           </p:nvPr>
         </p:nvSpPr>
-        <p:spPr>
-          <a:solidFill>
-            <a:srgbClr val="FFC003"/>
-          </a:solidFill>
-        </p:spPr>
+        <p:spPr/>
         <p:txBody>
           <a:bodyPr/>
           <a:lstStyle/>
           <a:p>
             <a:r>
-              <a:rPr lang="en-US" dirty="0">
-                <a:solidFill>
-                  <a:schemeClr val="bg1"/>
-                </a:solidFill>
-              </a:rPr>
-              <a:t>Alpha Diversity</a:t>
+              <a:rPr lang="en-US" dirty="0"/>
+              <a:t>ASV Richness</a:t>
             </a:r>
           </a:p>
         </p:txBody>
       </p:sp>
       <p:sp>
         <p:nvSpPr>
-          <p:cNvPr id="3" name="Content Placeholder 2">
+          <p:cNvPr id="6" name="TextBox 5">
             <a:extLst>
               <a:ext uri="{FF2B5EF4-FFF2-40B4-BE49-F238E27FC236}">
-                <a16:creationId xmlns:a16="http://schemas.microsoft.com/office/drawing/2014/main" id="{C8B28687-3A56-724D-832B-D6AF3CD1B17E}"/>
+                <a16:creationId xmlns:a16="http://schemas.microsoft.com/office/drawing/2014/main" id="{4AB9F72C-AE09-4F49-B874-949F669B1D4D}"/>
               </a:ext>
             </a:extLst>
           </p:cNvPr>
-          <p:cNvSpPr>
-            <a:spLocks noGrp="1"/>
-          </p:cNvSpPr>
-          <p:nvPr>
-            <p:ph idx="1"/>
-          </p:nvPr>
+          <p:cNvSpPr txBox="1"/>
+          <p:nvPr/>
         </p:nvSpPr>
         <p:spPr>
           <a:xfrm>
-            <a:off x="838200" y="5557837"/>
-            <a:ext cx="10515600" cy="619125"/>
+            <a:off x="624468" y="1952793"/>
+            <a:ext cx="4958576" cy="3970318"/>
           </a:xfrm>
+          <a:prstGeom prst="rect">
+            <a:avLst/>
+          </a:prstGeom>
+          <a:noFill/>
         </p:spPr>
         <p:txBody>
-          <a:bodyPr>
-            <a:normAutofit fontScale="92500" lnSpcReduction="20000"/>
+          <a:bodyPr wrap="square" rtlCol="0">
+            <a:spAutoFit/>
           </a:bodyPr>
           <a:lstStyle/>
           <a:p>
-            <a:pPr marL="0" indent="0" algn="ctr">
-              <a:buNone/>
-            </a:pPr>
-            <a:r>
-              <a:rPr lang="en-US" sz="2400" dirty="0"/>
-              <a:t>Figure : </a:t>
-            </a:r>
-            <a:r>
-              <a:rPr lang="en-GB" sz="2400" dirty="0"/>
-              <a:t>Plots of ASV richness (A) and Shannon Diversity Index (B) for each glacier (richness: t = 2.0202, </a:t>
-            </a:r>
-            <a:r>
-              <a:rPr lang="en-GB" sz="2400" dirty="0" err="1"/>
+            <a:r>
+              <a:rPr lang="en-US" dirty="0"/>
+              <a:t>Comparison of ASV richness between Canada and Taylor glaciers</a:t>
+            </a:r>
+          </a:p>
+          <a:p>
+            <a:endParaRPr lang="en-US" dirty="0"/>
+          </a:p>
+          <a:p>
+            <a:r>
+              <a:rPr lang="en-US" dirty="0"/>
+              <a:t>Total community: Parametric assumptions met. Unpaired two-sample t-test showed no significant difference (t=1.97, </a:t>
+            </a:r>
+            <a:r>
+              <a:rPr lang="en-US" dirty="0" err="1"/>
               <a:t>df</a:t>
             </a:r>
             <a:r>
-              <a:rPr lang="en-GB" sz="2400" dirty="0"/>
-              <a:t> = 32, p=0.0518, Shannon: W = 142, p=0.5808)</a:t>
-            </a:r>
-            <a:endParaRPr lang="en-US" sz="2400" dirty="0"/>
+              <a:rPr lang="en-US" dirty="0"/>
+              <a:t>=32, p=0.57)</a:t>
+            </a:r>
+          </a:p>
+          <a:p>
+            <a:endParaRPr lang="en-US" dirty="0"/>
+          </a:p>
+          <a:p>
+            <a:r>
+              <a:rPr lang="en-US" dirty="0"/>
+              <a:t>Abundant community: Parametric assumptions not met. Unpaired two samples Wilcoxon test showed no significant difference (W=179.5, p= 0.053)</a:t>
+            </a:r>
+          </a:p>
+          <a:p>
+            <a:endParaRPr lang="en-US" dirty="0"/>
+          </a:p>
+          <a:p>
+            <a:r>
+              <a:rPr lang="en-US" dirty="0"/>
+              <a:t>Rare community: Parametric assumptions met. Unpaired two-sample t-test showed no significant difference (t=1.04, </a:t>
+            </a:r>
+            <a:r>
+              <a:rPr lang="en-US" dirty="0" err="1"/>
+              <a:t>df</a:t>
+            </a:r>
+            <a:r>
+              <a:rPr lang="en-US" dirty="0"/>
+              <a:t>=32, p=0.31)</a:t>
+            </a:r>
           </a:p>
         </p:txBody>
       </p:sp>
       <p:pic>
         <p:nvPicPr>
-          <p:cNvPr id="5" name="Picture 4">
+          <p:cNvPr id="9" name="Picture 8">
             <a:extLst>
               <a:ext uri="{FF2B5EF4-FFF2-40B4-BE49-F238E27FC236}">
-                <a16:creationId xmlns:a16="http://schemas.microsoft.com/office/drawing/2014/main" id="{4FB688A8-5093-E44A-998C-E2EA4D158E52}"/>
+                <a16:creationId xmlns:a16="http://schemas.microsoft.com/office/drawing/2014/main" id="{F87AF4B3-4B97-A444-B02D-FC78B4B63752}"/>
+              </a:ext>
+            </a:extLst>
+          </p:cNvPr>
+          <p:cNvPicPr>
+            <a:picLocks noChangeAspect="1"/>
+          </p:cNvPicPr>
+          <p:nvPr/>
+        </p:nvPicPr>
+        <p:blipFill>
+          <a:blip r:embed="rId2"/>
+          <a:stretch>
+            <a:fillRect/>
+          </a:stretch>
+        </p:blipFill>
+        <p:spPr>
+          <a:xfrm>
+            <a:off x="5583044" y="602166"/>
+            <a:ext cx="5885182" cy="5885182"/>
+          </a:xfrm>
+          <a:prstGeom prst="rect">
+            <a:avLst/>
+          </a:prstGeom>
+        </p:spPr>
+      </p:pic>
+      <p:pic>
+        <p:nvPicPr>
+          <p:cNvPr id="11" name="Picture 10">
+            <a:extLst>
+              <a:ext uri="{FF2B5EF4-FFF2-40B4-BE49-F238E27FC236}">
+                <a16:creationId xmlns:a16="http://schemas.microsoft.com/office/drawing/2014/main" id="{8063C75D-FC2C-4340-B1EE-BF4C87B7B4F2}"/>
               </a:ext>
             </a:extLst>
           </p:cNvPr>
@@ -34734,8 +35306,8 @@
         </p:blipFill>
         <p:spPr>
           <a:xfrm>
-            <a:off x="2438400" y="1795463"/>
-            <a:ext cx="7315200" cy="3657600"/>
+            <a:off x="8377216" y="3969835"/>
+            <a:ext cx="3429758" cy="1534864"/>
           </a:xfrm>
           <a:prstGeom prst="rect">
             <a:avLst/>
@@ -34745,7 +35317,7 @@
     </p:spTree>
     <p:extLst>
       <p:ext uri="{BB962C8B-B14F-4D97-AF65-F5344CB8AC3E}">
-        <p14:creationId xmlns:p14="http://schemas.microsoft.com/office/powerpoint/2010/main" val="3700840866"/>
+        <p14:creationId xmlns:p14="http://schemas.microsoft.com/office/powerpoint/2010/main" val="3422781684"/>
       </p:ext>
     </p:extLst>
   </p:cSld>

</xml_diff>